<commit_message>
add stddev to important tables in pptx
</commit_message>
<xml_diff>
--- a/Prezentacija/Varijacijsko učenje na zašumljenim oznakama.pptx
+++ b/Prezentacija/Varijacijsko učenje na zašumljenim oznakama.pptx
@@ -219,7 +219,7 @@
           <a:p>
             <a:fld id="{4EC22A23-FA0E-43FF-AD6A-5A9DC9E7A77F}" type="datetimeFigureOut">
               <a:rPr lang="hr-HR" smtClean="0"/>
-              <a:t>6.7.2025.</a:t>
+              <a:t>8.7.2025.</a:t>
             </a:fld>
             <a:endParaRPr lang="hr-HR"/>
           </a:p>
@@ -765,7 +765,7 @@
           <a:p>
             <a:fld id="{08F0DB6F-6EB1-4D7D-9BCC-E96C905FFC52}" type="datetime1">
               <a:rPr lang="hr-HR" smtClean="0"/>
-              <a:t>6.7.2025.</a:t>
+              <a:t>8.7.2025.</a:t>
             </a:fld>
             <a:endParaRPr lang="hr-HR"/>
           </a:p>
@@ -935,7 +935,7 @@
           <a:p>
             <a:fld id="{1D8897EE-C1D5-4E52-876C-358FABA2E6DD}" type="datetime1">
               <a:rPr lang="hr-HR" smtClean="0"/>
-              <a:t>6.7.2025.</a:t>
+              <a:t>8.7.2025.</a:t>
             </a:fld>
             <a:endParaRPr lang="hr-HR"/>
           </a:p>
@@ -1156,7 +1156,7 @@
           <a:p>
             <a:fld id="{846F014D-1E5A-4CE6-87B2-A696E1D2C514}" type="datetime1">
               <a:rPr lang="hr-HR" smtClean="0"/>
-              <a:t>6.7.2025.</a:t>
+              <a:t>8.7.2025.</a:t>
             </a:fld>
             <a:endParaRPr lang="hr-HR"/>
           </a:p>
@@ -1367,7 +1367,7 @@
           <a:p>
             <a:fld id="{CC657D9C-C0AF-48FA-BBAF-7CAA57C23F8E}" type="datetime1">
               <a:rPr lang="hr-HR" smtClean="0"/>
-              <a:t>6.7.2025.</a:t>
+              <a:t>8.7.2025.</a:t>
             </a:fld>
             <a:endParaRPr lang="hr-HR"/>
           </a:p>
@@ -1662,7 +1662,7 @@
           <a:p>
             <a:fld id="{70E6B098-981F-45CA-83FF-788349BDC294}" type="datetime1">
               <a:rPr lang="hr-HR" smtClean="0"/>
-              <a:t>6.7.2025.</a:t>
+              <a:t>8.7.2025.</a:t>
             </a:fld>
             <a:endParaRPr lang="hr-HR"/>
           </a:p>
@@ -1991,7 +1991,7 @@
           <a:p>
             <a:fld id="{8F06E4C2-5A97-4809-9A3F-0AD2CD797138}" type="datetime1">
               <a:rPr lang="hr-HR" smtClean="0"/>
-              <a:t>6.7.2025.</a:t>
+              <a:t>8.7.2025.</a:t>
             </a:fld>
             <a:endParaRPr lang="hr-HR"/>
           </a:p>
@@ -2483,7 +2483,7 @@
           <a:p>
             <a:fld id="{7760B546-6293-4D30-BD97-A6B6A01C90BF}" type="datetime1">
               <a:rPr lang="hr-HR" smtClean="0"/>
-              <a:t>6.7.2025.</a:t>
+              <a:t>8.7.2025.</a:t>
             </a:fld>
             <a:endParaRPr lang="hr-HR"/>
           </a:p>
@@ -2642,7 +2642,7 @@
           <a:p>
             <a:fld id="{C5F7632D-88EC-4C5E-9269-EEF5AECE77DB}" type="datetime1">
               <a:rPr lang="hr-HR" smtClean="0"/>
-              <a:t>6.7.2025.</a:t>
+              <a:t>8.7.2025.</a:t>
             </a:fld>
             <a:endParaRPr lang="hr-HR"/>
           </a:p>
@@ -2778,7 +2778,7 @@
           <a:p>
             <a:fld id="{40E43FE3-F849-413C-9C82-49701E1B3EF3}" type="datetime1">
               <a:rPr lang="hr-HR" smtClean="0"/>
-              <a:t>6.7.2025.</a:t>
+              <a:t>8.7.2025.</a:t>
             </a:fld>
             <a:endParaRPr lang="hr-HR"/>
           </a:p>
@@ -3106,7 +3106,7 @@
           <a:p>
             <a:fld id="{058D4826-6613-4A6F-B53D-11761422A9FC}" type="datetime1">
               <a:rPr lang="hr-HR" smtClean="0"/>
-              <a:t>6.7.2025.</a:t>
+              <a:t>8.7.2025.</a:t>
             </a:fld>
             <a:endParaRPr lang="hr-HR"/>
           </a:p>
@@ -3421,7 +3421,7 @@
           <a:p>
             <a:fld id="{CB3A042B-28D4-4EE9-A191-0F90C01EB3D9}" type="datetime1">
               <a:rPr lang="hr-HR" smtClean="0"/>
-              <a:t>6.7.2025.</a:t>
+              <a:t>8.7.2025.</a:t>
             </a:fld>
             <a:endParaRPr lang="hr-HR"/>
           </a:p>
@@ -3673,7 +3673,7 @@
           <a:p>
             <a:fld id="{DE49A88E-18D6-498E-8265-50D671D76CD0}" type="datetime1">
               <a:rPr lang="hr-HR" smtClean="0"/>
-              <a:t>6.7.2025.</a:t>
+              <a:t>8.7.2025.</a:t>
             </a:fld>
             <a:endParaRPr lang="hr-HR"/>
           </a:p>
@@ -4986,27 +4986,27 @@
         <p:spPr>
           <a:xfrm>
             <a:off x="1261872" y="1828800"/>
-            <a:ext cx="9267046" cy="4735002"/>
+            <a:ext cx="9267046" cy="4814455"/>
           </a:xfrm>
         </p:spPr>
         <p:txBody>
           <a:bodyPr>
-            <a:normAutofit lnSpcReduction="10000"/>
+            <a:normAutofit/>
           </a:bodyPr>
           <a:lstStyle/>
+          <a:p>
+            <a:r>
+              <a:rPr lang="hr-HR" sz="2600" dirty="0">
+                <a:latin typeface="Arial" panose="020B0604020202020204" pitchFamily="34" charset="0"/>
+                <a:cs typeface="Arial" panose="020B0604020202020204" pitchFamily="34" charset="0"/>
+              </a:rPr>
+              <a:t>3 ponavljanja pojedinih eksperimenata</a:t>
+            </a:r>
+          </a:p>
           <a:p>
             <a:pPr marL="0" indent="0">
               <a:buNone/>
             </a:pPr>
-            <a:endParaRPr lang="hr-HR" sz="2600" dirty="0">
-              <a:latin typeface="Arial" panose="020B0604020202020204" pitchFamily="34" charset="0"/>
-              <a:cs typeface="Arial" panose="020B0604020202020204" pitchFamily="34" charset="0"/>
-            </a:endParaRPr>
-          </a:p>
-          <a:p>
-            <a:pPr marL="0" indent="0">
-              <a:buNone/>
-            </a:pPr>
             <a:r>
               <a:rPr lang="hr-HR" sz="2600" dirty="0">
                 <a:latin typeface="Arial" panose="020B0604020202020204" pitchFamily="34" charset="0"/>
@@ -5128,9 +5128,6 @@
               </a:rPr>
               <a:t>na čistom skupu</a:t>
             </a:r>
-          </a:p>
-          <a:p>
-            <a:pPr lvl="1"/>
             <a:endParaRPr lang="hr-HR" sz="2600" noProof="0" dirty="0">
               <a:latin typeface="Arial" panose="020B0604020202020204" pitchFamily="34" charset="0"/>
               <a:cs typeface="Arial" panose="020B0604020202020204" pitchFamily="34" charset="0"/>
@@ -5296,7 +5293,7 @@
               </a:rPr>
               <a:t>– ASR)</a:t>
             </a:r>
-            <a:endParaRPr lang="hr-HR" sz="2600" noProof="0" dirty="0">
+            <a:endParaRPr lang="en-US" sz="2600" dirty="0">
               <a:latin typeface="Arial" panose="020B0604020202020204" pitchFamily="34" charset="0"/>
               <a:cs typeface="Arial" panose="020B0604020202020204" pitchFamily="34" charset="0"/>
             </a:endParaRPr>
@@ -5820,6 +5817,36 @@
           <a:chExt cx="0" cy="0"/>
         </a:xfrm>
       </p:grpSpPr>
+      <p:pic>
+        <p:nvPicPr>
+          <p:cNvPr id="12" name="Picture 11">
+            <a:extLst>
+              <a:ext uri="{FF2B5EF4-FFF2-40B4-BE49-F238E27FC236}">
+                <a16:creationId xmlns:a16="http://schemas.microsoft.com/office/drawing/2014/main" id="{E95A67E5-079A-6313-575A-9F9089293D4F}"/>
+              </a:ext>
+            </a:extLst>
+          </p:cNvPr>
+          <p:cNvPicPr>
+            <a:picLocks noChangeAspect="1"/>
+          </p:cNvPicPr>
+          <p:nvPr/>
+        </p:nvPicPr>
+        <p:blipFill>
+          <a:blip r:embed="rId2"/>
+          <a:stretch>
+            <a:fillRect/>
+          </a:stretch>
+        </p:blipFill>
+        <p:spPr>
+          <a:xfrm>
+            <a:off x="4120950" y="4259702"/>
+            <a:ext cx="3248478" cy="2076740"/>
+          </a:xfrm>
+          <a:prstGeom prst="rect">
+            <a:avLst/>
+          </a:prstGeom>
+        </p:spPr>
+      </p:pic>
       <p:sp>
         <p:nvSpPr>
           <p:cNvPr id="11" name="Content Placeholder 2">
@@ -6297,36 +6324,6 @@
           </a:p>
         </p:txBody>
       </p:sp>
-      <p:pic>
-        <p:nvPicPr>
-          <p:cNvPr id="9" name="Picture 8">
-            <a:extLst>
-              <a:ext uri="{FF2B5EF4-FFF2-40B4-BE49-F238E27FC236}">
-                <a16:creationId xmlns:a16="http://schemas.microsoft.com/office/drawing/2014/main" id="{6E53711F-750A-E518-B807-C09926D6886A}"/>
-              </a:ext>
-            </a:extLst>
-          </p:cNvPr>
-          <p:cNvPicPr>
-            <a:picLocks noChangeAspect="1"/>
-          </p:cNvPicPr>
-          <p:nvPr/>
-        </p:nvPicPr>
-        <p:blipFill>
-          <a:blip r:embed="rId2"/>
-          <a:stretch>
-            <a:fillRect/>
-          </a:stretch>
-        </p:blipFill>
-        <p:spPr>
-          <a:xfrm>
-            <a:off x="4130476" y="4245413"/>
-            <a:ext cx="3229426" cy="2105319"/>
-          </a:xfrm>
-          <a:prstGeom prst="rect">
-            <a:avLst/>
-          </a:prstGeom>
-        </p:spPr>
-      </p:pic>
     </p:spTree>
     <p:extLst>
       <p:ext uri="{BB962C8B-B14F-4D97-AF65-F5344CB8AC3E}">
@@ -6477,10 +6474,10 @@
       </p:sp>
       <p:grpSp>
         <p:nvGrpSpPr>
-          <p:cNvPr id="12" name="Group 11">
+          <p:cNvPr id="13" name="Group 12">
             <a:extLst>
               <a:ext uri="{FF2B5EF4-FFF2-40B4-BE49-F238E27FC236}">
-                <a16:creationId xmlns:a16="http://schemas.microsoft.com/office/drawing/2014/main" id="{FEED14FE-4F5C-3879-9E99-1854608330F2}"/>
+                <a16:creationId xmlns:a16="http://schemas.microsoft.com/office/drawing/2014/main" id="{85E2528B-CAAA-8B27-CC59-FAA7B4001872}"/>
               </a:ext>
             </a:extLst>
           </p:cNvPr>
@@ -6489,179 +6486,221 @@
         </p:nvGrpSpPr>
         <p:grpSpPr>
           <a:xfrm>
-            <a:off x="1031044" y="2507345"/>
-            <a:ext cx="9749352" cy="3750340"/>
-            <a:chOff x="1261872" y="2036830"/>
-            <a:chExt cx="9749352" cy="3750340"/>
+            <a:off x="791569" y="2505759"/>
+            <a:ext cx="10359850" cy="3751926"/>
+            <a:chOff x="877569" y="2504075"/>
+            <a:chExt cx="10359850" cy="3751926"/>
           </a:xfrm>
         </p:grpSpPr>
-        <p:sp>
-          <p:nvSpPr>
-            <p:cNvPr id="25" name="TextBox 24">
+        <p:grpSp>
+          <p:nvGrpSpPr>
+            <p:cNvPr id="10" name="Group 9">
               <a:extLst>
                 <a:ext uri="{FF2B5EF4-FFF2-40B4-BE49-F238E27FC236}">
-                  <a16:creationId xmlns:a16="http://schemas.microsoft.com/office/drawing/2014/main" id="{7C0F6ED8-F856-7668-D143-B0F3237E447B}"/>
+                  <a16:creationId xmlns:a16="http://schemas.microsoft.com/office/drawing/2014/main" id="{4924F0A2-8B55-BC04-6C9E-2F58244C3025}"/>
                 </a:ext>
               </a:extLst>
             </p:cNvPr>
-            <p:cNvSpPr txBox="1"/>
+            <p:cNvGrpSpPr/>
             <p:nvPr/>
-          </p:nvSpPr>
-          <p:spPr>
+          </p:nvGrpSpPr>
+          <p:grpSpPr>
             <a:xfrm>
-              <a:off x="1261872" y="2036831"/>
-              <a:ext cx="4541832" cy="492443"/>
+              <a:off x="877569" y="2504075"/>
+              <a:ext cx="5818018" cy="3751926"/>
+              <a:chOff x="596189" y="2504075"/>
+              <a:chExt cx="5818018" cy="3751926"/>
             </a:xfrm>
-            <a:prstGeom prst="rect">
-              <a:avLst/>
-            </a:prstGeom>
-            <a:noFill/>
-          </p:spPr>
-          <p:txBody>
-            <a:bodyPr wrap="square" rtlCol="0">
-              <a:spAutoFit/>
-            </a:bodyPr>
-            <a:lstStyle/>
-            <a:p>
-              <a:pPr algn="ctr"/>
-              <a:r>
-                <a:rPr lang="hr-HR" sz="2600" b="1" dirty="0">
-                  <a:solidFill>
-                    <a:schemeClr val="tx1">
-                      <a:lumMod val="65000"/>
-                      <a:lumOff val="35000"/>
-                    </a:schemeClr>
-                  </a:solidFill>
-                  <a:latin typeface="Arial" panose="020B0604020202020204" pitchFamily="34" charset="0"/>
-                  <a:cs typeface="Arial" panose="020B0604020202020204" pitchFamily="34" charset="0"/>
-                </a:rPr>
-                <a:t>Simetrično zašumljivanje</a:t>
-              </a:r>
-            </a:p>
-          </p:txBody>
-        </p:sp>
-        <p:sp>
-          <p:nvSpPr>
-            <p:cNvPr id="26" name="TextBox 25">
+          </p:grpSpPr>
+          <p:pic>
+            <p:nvPicPr>
+              <p:cNvPr id="4" name="Picture 3">
+                <a:extLst>
+                  <a:ext uri="{FF2B5EF4-FFF2-40B4-BE49-F238E27FC236}">
+                    <a16:creationId xmlns:a16="http://schemas.microsoft.com/office/drawing/2014/main" id="{5E83B980-F48B-E3BA-B57A-0F89DCCAC198}"/>
+                  </a:ext>
+                </a:extLst>
+              </p:cNvPr>
+              <p:cNvPicPr>
+                <a:picLocks noChangeAspect="1"/>
+              </p:cNvPicPr>
+              <p:nvPr/>
+            </p:nvPicPr>
+            <p:blipFill>
+              <a:blip r:embed="rId2"/>
+              <a:srcRect l="695"/>
+              <a:stretch>
+                <a:fillRect/>
+              </a:stretch>
+            </p:blipFill>
+            <p:spPr>
+              <a:xfrm>
+                <a:off x="596189" y="3178997"/>
+                <a:ext cx="5818018" cy="3077004"/>
+              </a:xfrm>
+              <a:prstGeom prst="rect">
+                <a:avLst/>
+              </a:prstGeom>
+            </p:spPr>
+          </p:pic>
+          <p:sp>
+            <p:nvSpPr>
+              <p:cNvPr id="25" name="TextBox 24">
+                <a:extLst>
+                  <a:ext uri="{FF2B5EF4-FFF2-40B4-BE49-F238E27FC236}">
+                    <a16:creationId xmlns:a16="http://schemas.microsoft.com/office/drawing/2014/main" id="{7C0F6ED8-F856-7668-D143-B0F3237E447B}"/>
+                  </a:ext>
+                </a:extLst>
+              </p:cNvPr>
+              <p:cNvSpPr txBox="1"/>
+              <p:nvPr/>
+            </p:nvSpPr>
+            <p:spPr>
+              <a:xfrm>
+                <a:off x="1234282" y="2504075"/>
+                <a:ext cx="4541832" cy="492443"/>
+              </a:xfrm>
+              <a:prstGeom prst="rect">
+                <a:avLst/>
+              </a:prstGeom>
+              <a:noFill/>
+            </p:spPr>
+            <p:txBody>
+              <a:bodyPr wrap="square" rtlCol="0">
+                <a:spAutoFit/>
+              </a:bodyPr>
+              <a:lstStyle/>
+              <a:p>
+                <a:pPr algn="ctr"/>
+                <a:r>
+                  <a:rPr lang="hr-HR" sz="2600" b="1" dirty="0">
+                    <a:solidFill>
+                      <a:schemeClr val="tx1">
+                        <a:lumMod val="65000"/>
+                        <a:lumOff val="35000"/>
+                      </a:schemeClr>
+                    </a:solidFill>
+                    <a:latin typeface="Arial" panose="020B0604020202020204" pitchFamily="34" charset="0"/>
+                    <a:cs typeface="Arial" panose="020B0604020202020204" pitchFamily="34" charset="0"/>
+                  </a:rPr>
+                  <a:t>Simetrično zašumljivanje</a:t>
+                </a:r>
+              </a:p>
+            </p:txBody>
+          </p:sp>
+        </p:grpSp>
+        <p:grpSp>
+          <p:nvGrpSpPr>
+            <p:cNvPr id="9" name="Group 8">
               <a:extLst>
                 <a:ext uri="{FF2B5EF4-FFF2-40B4-BE49-F238E27FC236}">
-                  <a16:creationId xmlns:a16="http://schemas.microsoft.com/office/drawing/2014/main" id="{709791A7-68A4-7211-9B53-9E5BF6FF9236}"/>
+                  <a16:creationId xmlns:a16="http://schemas.microsoft.com/office/drawing/2014/main" id="{6C949B59-3227-2718-5513-CA295B1C8C86}"/>
                 </a:ext>
               </a:extLst>
             </p:cNvPr>
-            <p:cNvSpPr txBox="1"/>
+            <p:cNvGrpSpPr/>
             <p:nvPr/>
-          </p:nvSpPr>
-          <p:spPr>
+          </p:nvGrpSpPr>
+          <p:grpSpPr>
             <a:xfrm>
-              <a:off x="6469392" y="2036830"/>
-              <a:ext cx="4541832" cy="892552"/>
+              <a:off x="6695587" y="2505661"/>
+              <a:ext cx="4541832" cy="3750340"/>
+              <a:chOff x="6245690" y="2505661"/>
+              <a:chExt cx="4541832" cy="3750340"/>
             </a:xfrm>
-            <a:prstGeom prst="rect">
-              <a:avLst/>
-            </a:prstGeom>
-            <a:noFill/>
-          </p:spPr>
-          <p:txBody>
-            <a:bodyPr wrap="square" rtlCol="0">
-              <a:spAutoFit/>
-            </a:bodyPr>
-            <a:lstStyle/>
-            <a:p>
-              <a:pPr algn="ctr"/>
-              <a:r>
-                <a:rPr lang="hr-HR" sz="2600" b="1" dirty="0">
-                  <a:solidFill>
-                    <a:schemeClr val="tx1">
-                      <a:lumMod val="65000"/>
-                      <a:lumOff val="35000"/>
-                    </a:schemeClr>
-                  </a:solidFill>
-                  <a:latin typeface="Arial" panose="020B0604020202020204" pitchFamily="34" charset="0"/>
-                  <a:cs typeface="Arial" panose="020B0604020202020204" pitchFamily="34" charset="0"/>
-                </a:rPr>
-                <a:t>Asimetrično zašumljivanje,</a:t>
-              </a:r>
-            </a:p>
-            <a:p>
-              <a:pPr algn="ctr"/>
-              <a:r>
-                <a:rPr lang="hr-HR" sz="2600" b="1" dirty="0">
-                  <a:solidFill>
-                    <a:schemeClr val="tx1">
-                      <a:lumMod val="65000"/>
-                      <a:lumOff val="35000"/>
-                    </a:schemeClr>
-                  </a:solidFill>
-                  <a:latin typeface="Arial" panose="020B0604020202020204" pitchFamily="34" charset="0"/>
-                  <a:cs typeface="Arial" panose="020B0604020202020204" pitchFamily="34" charset="0"/>
-                </a:rPr>
-                <a:t>stopa šuma 40%</a:t>
-              </a:r>
-            </a:p>
-          </p:txBody>
-        </p:sp>
-        <p:pic>
-          <p:nvPicPr>
-            <p:cNvPr id="30" name="Picture 29">
-              <a:extLst>
-                <a:ext uri="{FF2B5EF4-FFF2-40B4-BE49-F238E27FC236}">
-                  <a16:creationId xmlns:a16="http://schemas.microsoft.com/office/drawing/2014/main" id="{BA433559-7543-44F0-127F-E1396F22924D}"/>
-                </a:ext>
-              </a:extLst>
-            </p:cNvPr>
-            <p:cNvPicPr>
-              <a:picLocks noChangeAspect="1"/>
-            </p:cNvPicPr>
-            <p:nvPr/>
-          </p:nvPicPr>
-          <p:blipFill>
-            <a:blip r:embed="rId2"/>
-            <a:stretch>
-              <a:fillRect/>
-            </a:stretch>
-          </p:blipFill>
-          <p:spPr>
-            <a:xfrm>
-              <a:off x="1379837" y="2670376"/>
-              <a:ext cx="4305901" cy="3115110"/>
-            </a:xfrm>
-            <a:prstGeom prst="rect">
-              <a:avLst/>
-            </a:prstGeom>
-          </p:spPr>
-        </p:pic>
-        <p:pic>
-          <p:nvPicPr>
-            <p:cNvPr id="32" name="Picture 31">
-              <a:extLst>
-                <a:ext uri="{FF2B5EF4-FFF2-40B4-BE49-F238E27FC236}">
-                  <a16:creationId xmlns:a16="http://schemas.microsoft.com/office/drawing/2014/main" id="{C0950E4D-E91C-3DBE-DF61-6627B398A128}"/>
-                </a:ext>
-              </a:extLst>
-            </p:cNvPr>
-            <p:cNvPicPr>
-              <a:picLocks noChangeAspect="1"/>
-            </p:cNvPicPr>
-            <p:nvPr/>
-          </p:nvPicPr>
-          <p:blipFill>
-            <a:blip r:embed="rId3"/>
-            <a:srcRect t="-1" b="586"/>
-            <a:stretch>
-              <a:fillRect/>
-            </a:stretch>
-          </p:blipFill>
-          <p:spPr>
-            <a:xfrm>
-              <a:off x="7116069" y="2993390"/>
-              <a:ext cx="3248478" cy="2793780"/>
-            </a:xfrm>
-            <a:prstGeom prst="rect">
-              <a:avLst/>
-            </a:prstGeom>
-          </p:spPr>
-        </p:pic>
+          </p:grpSpPr>
+          <p:pic>
+            <p:nvPicPr>
+              <p:cNvPr id="7" name="Picture 6">
+                <a:extLst>
+                  <a:ext uri="{FF2B5EF4-FFF2-40B4-BE49-F238E27FC236}">
+                    <a16:creationId xmlns:a16="http://schemas.microsoft.com/office/drawing/2014/main" id="{F0FA2FEA-7BEA-E62A-C430-ABF611962E96}"/>
+                  </a:ext>
+                </a:extLst>
+              </p:cNvPr>
+              <p:cNvPicPr>
+                <a:picLocks noChangeAspect="1"/>
+              </p:cNvPicPr>
+              <p:nvPr/>
+            </p:nvPicPr>
+            <p:blipFill>
+              <a:blip r:embed="rId3"/>
+              <a:stretch>
+                <a:fillRect/>
+              </a:stretch>
+            </p:blipFill>
+            <p:spPr>
+              <a:xfrm>
+                <a:off x="6911419" y="3493365"/>
+                <a:ext cx="3210373" cy="2762636"/>
+              </a:xfrm>
+              <a:prstGeom prst="rect">
+                <a:avLst/>
+              </a:prstGeom>
+            </p:spPr>
+          </p:pic>
+          <p:sp>
+            <p:nvSpPr>
+              <p:cNvPr id="26" name="TextBox 25">
+                <a:extLst>
+                  <a:ext uri="{FF2B5EF4-FFF2-40B4-BE49-F238E27FC236}">
+                    <a16:creationId xmlns:a16="http://schemas.microsoft.com/office/drawing/2014/main" id="{709791A7-68A4-7211-9B53-9E5BF6FF9236}"/>
+                  </a:ext>
+                </a:extLst>
+              </p:cNvPr>
+              <p:cNvSpPr txBox="1"/>
+              <p:nvPr/>
+            </p:nvSpPr>
+            <p:spPr>
+              <a:xfrm>
+                <a:off x="6245690" y="2505661"/>
+                <a:ext cx="4541832" cy="892552"/>
+              </a:xfrm>
+              <a:prstGeom prst="rect">
+                <a:avLst/>
+              </a:prstGeom>
+              <a:noFill/>
+            </p:spPr>
+            <p:txBody>
+              <a:bodyPr wrap="square" rtlCol="0">
+                <a:spAutoFit/>
+              </a:bodyPr>
+              <a:lstStyle/>
+              <a:p>
+                <a:pPr algn="ctr"/>
+                <a:r>
+                  <a:rPr lang="hr-HR" sz="2600" b="1" dirty="0">
+                    <a:solidFill>
+                      <a:schemeClr val="tx1">
+                        <a:lumMod val="65000"/>
+                        <a:lumOff val="35000"/>
+                      </a:schemeClr>
+                    </a:solidFill>
+                    <a:latin typeface="Arial" panose="020B0604020202020204" pitchFamily="34" charset="0"/>
+                    <a:cs typeface="Arial" panose="020B0604020202020204" pitchFamily="34" charset="0"/>
+                  </a:rPr>
+                  <a:t>Asimetrično zašumljivanje,</a:t>
+                </a:r>
+              </a:p>
+              <a:p>
+                <a:pPr algn="ctr"/>
+                <a:r>
+                  <a:rPr lang="hr-HR" sz="2600" b="1" dirty="0">
+                    <a:solidFill>
+                      <a:schemeClr val="tx1">
+                        <a:lumMod val="65000"/>
+                        <a:lumOff val="35000"/>
+                      </a:schemeClr>
+                    </a:solidFill>
+                    <a:latin typeface="Arial" panose="020B0604020202020204" pitchFamily="34" charset="0"/>
+                    <a:cs typeface="Arial" panose="020B0604020202020204" pitchFamily="34" charset="0"/>
+                  </a:rPr>
+                  <a:t>stopa šuma 40%</a:t>
+                </a:r>
+              </a:p>
+            </p:txBody>
+          </p:sp>
+        </p:grpSp>
       </p:grpSp>
       <p:sp>
         <p:nvSpPr>
@@ -7447,10 +7486,10 @@
       </p:grpSpPr>
       <p:pic>
         <p:nvPicPr>
-          <p:cNvPr id="13" name="Picture 12">
+          <p:cNvPr id="12" name="Picture 11">
             <a:extLst>
               <a:ext uri="{FF2B5EF4-FFF2-40B4-BE49-F238E27FC236}">
-                <a16:creationId xmlns:a16="http://schemas.microsoft.com/office/drawing/2014/main" id="{473D17B6-8E40-5C5E-C348-EEBC0F13FE1E}"/>
+                <a16:creationId xmlns:a16="http://schemas.microsoft.com/office/drawing/2014/main" id="{39584BCB-5F06-51D3-B90B-1CDB2D646071}"/>
               </a:ext>
             </a:extLst>
           </p:cNvPr>
@@ -7467,8 +7506,8 @@
         </p:blipFill>
         <p:spPr>
           <a:xfrm>
-            <a:off x="2950133" y="5313480"/>
-            <a:ext cx="5753903" cy="1133633"/>
+            <a:off x="2973947" y="5229395"/>
+            <a:ext cx="5706271" cy="1066949"/>
           </a:xfrm>
           <a:prstGeom prst="rect">
             <a:avLst/>
@@ -7477,10 +7516,10 @@
       </p:pic>
       <p:pic>
         <p:nvPicPr>
-          <p:cNvPr id="10" name="Picture 9">
+          <p:cNvPr id="7" name="Picture 6">
             <a:extLst>
               <a:ext uri="{FF2B5EF4-FFF2-40B4-BE49-F238E27FC236}">
-                <a16:creationId xmlns:a16="http://schemas.microsoft.com/office/drawing/2014/main" id="{CDED3F8A-A4B6-FD23-E329-17555F39C9EF}"/>
+                <a16:creationId xmlns:a16="http://schemas.microsoft.com/office/drawing/2014/main" id="{86D0D81D-8C95-0230-DEE8-466204BCC512}"/>
               </a:ext>
             </a:extLst>
           </p:cNvPr>
@@ -7497,8 +7536,8 @@
         </p:blipFill>
         <p:spPr>
           <a:xfrm>
-            <a:off x="906736" y="2099630"/>
-            <a:ext cx="9840698" cy="2152950"/>
+            <a:off x="954366" y="2099630"/>
+            <a:ext cx="9745435" cy="2124371"/>
           </a:xfrm>
           <a:prstGeom prst="rect">
             <a:avLst/>
@@ -8736,10 +8775,10 @@
       </p:sp>
       <p:grpSp>
         <p:nvGrpSpPr>
-          <p:cNvPr id="26" name="Group 25">
+          <p:cNvPr id="28" name="Group 27">
             <a:extLst>
               <a:ext uri="{FF2B5EF4-FFF2-40B4-BE49-F238E27FC236}">
-                <a16:creationId xmlns:a16="http://schemas.microsoft.com/office/drawing/2014/main" id="{17C3C945-209C-6BE1-F94F-04F5637E7B61}"/>
+                <a16:creationId xmlns:a16="http://schemas.microsoft.com/office/drawing/2014/main" id="{10BB18CE-5CE4-9602-07DA-67086A27AEE8}"/>
               </a:ext>
             </a:extLst>
           </p:cNvPr>
@@ -8748,18 +8787,18 @@
         </p:nvGrpSpPr>
         <p:grpSpPr>
           <a:xfrm>
-            <a:off x="992447" y="1535306"/>
-            <a:ext cx="9792327" cy="5136862"/>
-            <a:chOff x="992447" y="1535306"/>
-            <a:chExt cx="9792327" cy="5136862"/>
+            <a:off x="949577" y="1535306"/>
+            <a:ext cx="9868538" cy="5165441"/>
+            <a:chOff x="949577" y="1535306"/>
+            <a:chExt cx="9868538" cy="5165441"/>
           </a:xfrm>
         </p:grpSpPr>
         <p:pic>
           <p:nvPicPr>
-            <p:cNvPr id="13" name="Picture 12">
+            <p:cNvPr id="22" name="Picture 21">
               <a:extLst>
                 <a:ext uri="{FF2B5EF4-FFF2-40B4-BE49-F238E27FC236}">
-                  <a16:creationId xmlns:a16="http://schemas.microsoft.com/office/drawing/2014/main" id="{02BEFB21-BD6B-5AC9-66C6-4DAA7C4B88C7}"/>
+                  <a16:creationId xmlns:a16="http://schemas.microsoft.com/office/drawing/2014/main" id="{A2243BF8-629F-44DB-0405-E099E156AD1A}"/>
                 </a:ext>
               </a:extLst>
             </p:cNvPr>
@@ -8776,8 +8815,38 @@
           </p:blipFill>
           <p:spPr>
             <a:xfrm>
-              <a:off x="992447" y="2031761"/>
-              <a:ext cx="4553585" cy="2095792"/>
+              <a:off x="3589741" y="4624007"/>
+              <a:ext cx="4582164" cy="2076740"/>
+            </a:xfrm>
+            <a:prstGeom prst="rect">
+              <a:avLst/>
+            </a:prstGeom>
+          </p:spPr>
+        </p:pic>
+        <p:pic>
+          <p:nvPicPr>
+            <p:cNvPr id="4" name="Picture 3">
+              <a:extLst>
+                <a:ext uri="{FF2B5EF4-FFF2-40B4-BE49-F238E27FC236}">
+                  <a16:creationId xmlns:a16="http://schemas.microsoft.com/office/drawing/2014/main" id="{443687AB-90A7-D788-42FE-B7F53CE37167}"/>
+                </a:ext>
+              </a:extLst>
+            </p:cNvPr>
+            <p:cNvPicPr>
+              <a:picLocks noChangeAspect="1"/>
+            </p:cNvPicPr>
+            <p:nvPr/>
+          </p:nvPicPr>
+          <p:blipFill>
+            <a:blip r:embed="rId4"/>
+            <a:stretch>
+              <a:fillRect/>
+            </a:stretch>
+          </p:blipFill>
+          <p:spPr>
+            <a:xfrm>
+              <a:off x="949577" y="2026997"/>
+              <a:ext cx="4639322" cy="2095792"/>
             </a:xfrm>
             <a:prstGeom prst="rect">
               <a:avLst/>
@@ -8921,41 +8990,10 @@
         </p:sp>
         <p:pic>
           <p:nvPicPr>
-            <p:cNvPr id="19" name="Picture 18">
+            <p:cNvPr id="20" name="Picture 19">
               <a:extLst>
                 <a:ext uri="{FF2B5EF4-FFF2-40B4-BE49-F238E27FC236}">
-                  <a16:creationId xmlns:a16="http://schemas.microsoft.com/office/drawing/2014/main" id="{CBA399A3-28C6-D9E0-7325-00D9FE7AD9FD}"/>
-                </a:ext>
-              </a:extLst>
-            </p:cNvPr>
-            <p:cNvPicPr>
-              <a:picLocks noChangeAspect="1"/>
-            </p:cNvPicPr>
-            <p:nvPr/>
-          </p:nvPicPr>
-          <p:blipFill>
-            <a:blip r:embed="rId4"/>
-            <a:srcRect t="450"/>
-            <a:stretch>
-              <a:fillRect/>
-            </a:stretch>
-          </p:blipFill>
-          <p:spPr>
-            <a:xfrm>
-              <a:off x="6231189" y="2026997"/>
-              <a:ext cx="4553585" cy="2105318"/>
-            </a:xfrm>
-            <a:prstGeom prst="rect">
-              <a:avLst/>
-            </a:prstGeom>
-          </p:spPr>
-        </p:pic>
-        <p:pic>
-          <p:nvPicPr>
-            <p:cNvPr id="25" name="Picture 24">
-              <a:extLst>
-                <a:ext uri="{FF2B5EF4-FFF2-40B4-BE49-F238E27FC236}">
-                  <a16:creationId xmlns:a16="http://schemas.microsoft.com/office/drawing/2014/main" id="{B6515943-AAEF-8966-0956-CA937860FA2C}"/>
+                  <a16:creationId xmlns:a16="http://schemas.microsoft.com/office/drawing/2014/main" id="{FC6D5ADC-1B79-4DCF-4A3A-DB02FAFDF8B1}"/>
                 </a:ext>
               </a:extLst>
             </p:cNvPr>
@@ -8972,8 +9010,8 @@
           </p:blipFill>
           <p:spPr>
             <a:xfrm>
-              <a:off x="3608793" y="4624007"/>
-              <a:ext cx="4544059" cy="2048161"/>
+              <a:off x="6197845" y="2026997"/>
+              <a:ext cx="4620270" cy="2095792"/>
             </a:xfrm>
             <a:prstGeom prst="rect">
               <a:avLst/>

</xml_diff>

<commit_message>
small main paper changes
</commit_message>
<xml_diff>
--- a/Prezentacija/Varijacijsko učenje na zašumljenim oznakama.pptx
+++ b/Prezentacija/Varijacijsko učenje na zašumljenim oznakama.pptx
@@ -219,7 +219,7 @@
           <a:p>
             <a:fld id="{4EC22A23-FA0E-43FF-AD6A-5A9DC9E7A77F}" type="datetimeFigureOut">
               <a:rPr lang="hr-HR" smtClean="0"/>
-              <a:t>8.7.2025.</a:t>
+              <a:t>10.7.2025.</a:t>
             </a:fld>
             <a:endParaRPr lang="hr-HR"/>
           </a:p>
@@ -765,7 +765,7 @@
           <a:p>
             <a:fld id="{08F0DB6F-6EB1-4D7D-9BCC-E96C905FFC52}" type="datetime1">
               <a:rPr lang="hr-HR" smtClean="0"/>
-              <a:t>8.7.2025.</a:t>
+              <a:t>10.7.2025.</a:t>
             </a:fld>
             <a:endParaRPr lang="hr-HR"/>
           </a:p>
@@ -935,7 +935,7 @@
           <a:p>
             <a:fld id="{1D8897EE-C1D5-4E52-876C-358FABA2E6DD}" type="datetime1">
               <a:rPr lang="hr-HR" smtClean="0"/>
-              <a:t>8.7.2025.</a:t>
+              <a:t>10.7.2025.</a:t>
             </a:fld>
             <a:endParaRPr lang="hr-HR"/>
           </a:p>
@@ -1156,7 +1156,7 @@
           <a:p>
             <a:fld id="{846F014D-1E5A-4CE6-87B2-A696E1D2C514}" type="datetime1">
               <a:rPr lang="hr-HR" smtClean="0"/>
-              <a:t>8.7.2025.</a:t>
+              <a:t>10.7.2025.</a:t>
             </a:fld>
             <a:endParaRPr lang="hr-HR"/>
           </a:p>
@@ -1367,7 +1367,7 @@
           <a:p>
             <a:fld id="{CC657D9C-C0AF-48FA-BBAF-7CAA57C23F8E}" type="datetime1">
               <a:rPr lang="hr-HR" smtClean="0"/>
-              <a:t>8.7.2025.</a:t>
+              <a:t>10.7.2025.</a:t>
             </a:fld>
             <a:endParaRPr lang="hr-HR"/>
           </a:p>
@@ -1662,7 +1662,7 @@
           <a:p>
             <a:fld id="{70E6B098-981F-45CA-83FF-788349BDC294}" type="datetime1">
               <a:rPr lang="hr-HR" smtClean="0"/>
-              <a:t>8.7.2025.</a:t>
+              <a:t>10.7.2025.</a:t>
             </a:fld>
             <a:endParaRPr lang="hr-HR"/>
           </a:p>
@@ -1991,7 +1991,7 @@
           <a:p>
             <a:fld id="{8F06E4C2-5A97-4809-9A3F-0AD2CD797138}" type="datetime1">
               <a:rPr lang="hr-HR" smtClean="0"/>
-              <a:t>8.7.2025.</a:t>
+              <a:t>10.7.2025.</a:t>
             </a:fld>
             <a:endParaRPr lang="hr-HR"/>
           </a:p>
@@ -2483,7 +2483,7 @@
           <a:p>
             <a:fld id="{7760B546-6293-4D30-BD97-A6B6A01C90BF}" type="datetime1">
               <a:rPr lang="hr-HR" smtClean="0"/>
-              <a:t>8.7.2025.</a:t>
+              <a:t>10.7.2025.</a:t>
             </a:fld>
             <a:endParaRPr lang="hr-HR"/>
           </a:p>
@@ -2642,7 +2642,7 @@
           <a:p>
             <a:fld id="{C5F7632D-88EC-4C5E-9269-EEF5AECE77DB}" type="datetime1">
               <a:rPr lang="hr-HR" smtClean="0"/>
-              <a:t>8.7.2025.</a:t>
+              <a:t>10.7.2025.</a:t>
             </a:fld>
             <a:endParaRPr lang="hr-HR"/>
           </a:p>
@@ -2778,7 +2778,7 @@
           <a:p>
             <a:fld id="{40E43FE3-F849-413C-9C82-49701E1B3EF3}" type="datetime1">
               <a:rPr lang="hr-HR" smtClean="0"/>
-              <a:t>8.7.2025.</a:t>
+              <a:t>10.7.2025.</a:t>
             </a:fld>
             <a:endParaRPr lang="hr-HR"/>
           </a:p>
@@ -3106,7 +3106,7 @@
           <a:p>
             <a:fld id="{058D4826-6613-4A6F-B53D-11761422A9FC}" type="datetime1">
               <a:rPr lang="hr-HR" smtClean="0"/>
-              <a:t>8.7.2025.</a:t>
+              <a:t>10.7.2025.</a:t>
             </a:fld>
             <a:endParaRPr lang="hr-HR"/>
           </a:p>
@@ -3421,7 +3421,7 @@
           <a:p>
             <a:fld id="{CB3A042B-28D4-4EE9-A191-0F90C01EB3D9}" type="datetime1">
               <a:rPr lang="hr-HR" smtClean="0"/>
-              <a:t>8.7.2025.</a:t>
+              <a:t>10.7.2025.</a:t>
             </a:fld>
             <a:endParaRPr lang="hr-HR"/>
           </a:p>
@@ -3673,7 +3673,7 @@
           <a:p>
             <a:fld id="{DE49A88E-18D6-498E-8265-50D671D76CD0}" type="datetime1">
               <a:rPr lang="hr-HR" smtClean="0"/>
-              <a:t>8.7.2025.</a:t>
+              <a:t>10.7.2025.</a:t>
             </a:fld>
             <a:endParaRPr lang="hr-HR"/>
           </a:p>
@@ -11595,10 +11595,10 @@
       </p:sp>
       <p:grpSp>
         <p:nvGrpSpPr>
-          <p:cNvPr id="17" name="Group 16">
+          <p:cNvPr id="13" name="Group 12">
             <a:extLst>
               <a:ext uri="{FF2B5EF4-FFF2-40B4-BE49-F238E27FC236}">
-                <a16:creationId xmlns:a16="http://schemas.microsoft.com/office/drawing/2014/main" id="{A6A95AE8-E5A2-F3A7-87EE-70DD803B443D}"/>
+                <a16:creationId xmlns:a16="http://schemas.microsoft.com/office/drawing/2014/main" id="{C3539D21-AAAA-D0D6-FFF8-8DFAF02C3A53}"/>
               </a:ext>
             </a:extLst>
           </p:cNvPr>
@@ -11607,10 +11607,10 @@
         </p:nvGrpSpPr>
         <p:grpSpPr>
           <a:xfrm>
-            <a:off x="2752542" y="2735846"/>
-            <a:ext cx="6711300" cy="2814377"/>
-            <a:chOff x="2733205" y="2662051"/>
-            <a:chExt cx="6711300" cy="2814377"/>
+            <a:off x="2633179" y="2735846"/>
+            <a:ext cx="6925642" cy="2814376"/>
+            <a:chOff x="2633179" y="2735846"/>
+            <a:chExt cx="6925642" cy="2814376"/>
           </a:xfrm>
         </p:grpSpPr>
         <p:pic>
@@ -11636,7 +11636,7 @@
           </p:blipFill>
           <p:spPr>
             <a:xfrm>
-              <a:off x="2733205" y="2662051"/>
+              <a:off x="2752542" y="2735846"/>
               <a:ext cx="6697010" cy="1267002"/>
             </a:xfrm>
             <a:prstGeom prst="rect">
@@ -11646,10 +11646,10 @@
         </p:pic>
         <p:pic>
           <p:nvPicPr>
-            <p:cNvPr id="16" name="Picture 15">
+            <p:cNvPr id="12" name="Picture 11">
               <a:extLst>
                 <a:ext uri="{FF2B5EF4-FFF2-40B4-BE49-F238E27FC236}">
-                  <a16:creationId xmlns:a16="http://schemas.microsoft.com/office/drawing/2014/main" id="{B8B67BB9-001D-C688-03B8-384A916E52E9}"/>
+                  <a16:creationId xmlns:a16="http://schemas.microsoft.com/office/drawing/2014/main" id="{F5B42B2E-EE9B-904B-B4FD-9264CC0BBA8C}"/>
                 </a:ext>
               </a:extLst>
             </p:cNvPr>
@@ -11666,8 +11666,8 @@
           </p:blipFill>
           <p:spPr>
             <a:xfrm>
-              <a:off x="2747495" y="4066531"/>
-              <a:ext cx="6697010" cy="1409897"/>
+              <a:off x="2633179" y="4140325"/>
+              <a:ext cx="6925642" cy="1409897"/>
             </a:xfrm>
             <a:prstGeom prst="rect">
               <a:avLst/>

</xml_diff>